<commit_message>
Redesign the dashboard as an aeronautical chart; refresh deck screenshots
Light chart paper, navy ink, magenta reserved for the plan. Line board as
labelled Gantt bars, availability as a chart scale bar with the plan's leg,
Barlow / Barlow Condensed with B612 Mono only for IDs. Night variant kept.

Co-Authored-By: Claude Opus 5.5 <noreply@anthropic.com>
</commit_message>
<xml_diff>
--- a/deck/FLIGHTLINE_SIH26249.pptx
+++ b/deck/FLIGHTLINE_SIH26249.pptx
@@ -116,30 +116,30 @@
   <p:extLst>
     <p:ext uri="{521415D9-36F7-43E2-AB2F-B90AF26B5E84}">
       <p14:sectionLst xmlns:p14="http://schemas.microsoft.com/office/powerpoint/2010/main">
-        <p14:section name="Title" id="{ef17ee91-589d-8c3f-739c-a78531119280}">
+        <p14:section name="Title" id="{a249e415-afad-a803-38c8-89ddc65ddc68}">
           <p14:sldIdLst>
             <p14:sldId id="256"/>
           </p14:sldIdLst>
         </p14:section>
-        <p14:section name="Problem and idea" id="{cbaba11e-55a0-7bce-d54a-23a88944651e}">
+        <p14:section name="Problem and idea" id="{b0bdbec6-43d5-d0e7-3a24-989a1805be96}">
           <p14:sldIdLst>
             <p14:sldId id="257"/>
             <p14:sldId id="258"/>
           </p14:sldIdLst>
         </p14:section>
-        <p14:section name="How it works" id="{31245f90-5e6c-1fae-c213-761e35f5ca81}">
+        <p14:section name="How it works" id="{182d69d5-71e1-7184-0f0d-2daa37d6a7b8}">
           <p14:sldIdLst>
             <p14:sldId id="259"/>
             <p14:sldId id="260"/>
             <p14:sldId id="261"/>
           </p14:sldIdLst>
         </p14:section>
-        <p14:section name="Demo" id="{51a8e016-39ff-8a87-4c7e-0c4952a02d80}">
+        <p14:section name="Demo" id="{69e4deac-7ff5-f330-8f66-c46086321345}">
           <p14:sldIdLst>
             <p14:sldId id="262"/>
           </p14:sldIdLst>
         </p14:section>
-        <p14:section name="Feasibility and impact" id="{55504a77-9131-0d30-958c-c62372835254}">
+        <p14:section name="Feasibility and impact" id="{0e3e05eb-9742-5c36-e04a-c0eeb1249455}">
           <p14:sldIdLst>
             <p14:sldId id="263"/>
             <p14:sldId id="264"/>
@@ -3294,7 +3294,7 @@
       </p:grpSpPr>
       <p:sp>
         <p:nvSpPr>
-          <p:cNvPr id="2" name="team-151"/>
+          <p:cNvPr id="2" name="team-149"/>
           <p:cNvSpPr/>
           <p:nvPr/>
         </p:nvSpPr>
@@ -3380,7 +3380,7 @@
       </p:sp>
       <p:sp>
         <p:nvSpPr>
-          <p:cNvPr id="4" name="card-152"/>
+          <p:cNvPr id="4" name="card-150"/>
           <p:cNvSpPr/>
           <p:nvPr/>
         </p:nvSpPr>
@@ -3405,7 +3405,7 @@
       </p:sp>
       <p:sp>
         <p:nvSpPr>
-          <p:cNvPr id="5" name="text-153"/>
+          <p:cNvPr id="5" name="text-151"/>
           <p:cNvSpPr txBox="1"/>
           <p:nvPr/>
         </p:nvSpPr>
@@ -3444,7 +3444,7 @@
       </p:sp>
       <p:sp>
         <p:nvSpPr>
-          <p:cNvPr id="6" name="text-154"/>
+          <p:cNvPr id="6" name="text-152"/>
           <p:cNvSpPr txBox="1"/>
           <p:nvPr/>
         </p:nvSpPr>
@@ -3483,7 +3483,7 @@
       </p:sp>
       <p:sp>
         <p:nvSpPr>
-          <p:cNvPr id="7" name="card-155"/>
+          <p:cNvPr id="7" name="card-153"/>
           <p:cNvSpPr/>
           <p:nvPr/>
         </p:nvSpPr>
@@ -3508,7 +3508,7 @@
       </p:sp>
       <p:sp>
         <p:nvSpPr>
-          <p:cNvPr id="8" name="text-156"/>
+          <p:cNvPr id="8" name="text-154"/>
           <p:cNvSpPr txBox="1"/>
           <p:nvPr/>
         </p:nvSpPr>
@@ -3547,7 +3547,7 @@
       </p:sp>
       <p:sp>
         <p:nvSpPr>
-          <p:cNvPr id="9" name="text-157"/>
+          <p:cNvPr id="9" name="text-155"/>
           <p:cNvSpPr txBox="1"/>
           <p:nvPr/>
         </p:nvSpPr>
@@ -3586,7 +3586,7 @@
       </p:sp>
       <p:sp>
         <p:nvSpPr>
-          <p:cNvPr id="10" name="card-158"/>
+          <p:cNvPr id="10" name="card-156"/>
           <p:cNvSpPr/>
           <p:nvPr/>
         </p:nvSpPr>
@@ -3611,7 +3611,7 @@
       </p:sp>
       <p:sp>
         <p:nvSpPr>
-          <p:cNvPr id="11" name="text-159"/>
+          <p:cNvPr id="11" name="text-157"/>
           <p:cNvSpPr txBox="1"/>
           <p:nvPr/>
         </p:nvSpPr>
@@ -3650,7 +3650,7 @@
       </p:sp>
       <p:sp>
         <p:nvSpPr>
-          <p:cNvPr id="12" name="text-160"/>
+          <p:cNvPr id="12" name="text-158"/>
           <p:cNvSpPr txBox="1"/>
           <p:nvPr/>
         </p:nvSpPr>
@@ -3689,7 +3689,7 @@
       </p:sp>
       <p:sp>
         <p:nvSpPr>
-          <p:cNvPr id="13" name="card-161"/>
+          <p:cNvPr id="13" name="card-159"/>
           <p:cNvSpPr/>
           <p:nvPr/>
         </p:nvSpPr>
@@ -3714,7 +3714,7 @@
       </p:sp>
       <p:sp>
         <p:nvSpPr>
-          <p:cNvPr id="14" name="text-162"/>
+          <p:cNvPr id="14" name="text-160"/>
           <p:cNvSpPr txBox="1"/>
           <p:nvPr/>
         </p:nvSpPr>
@@ -3753,7 +3753,7 @@
       </p:sp>
       <p:sp>
         <p:nvSpPr>
-          <p:cNvPr id="15" name="text-163"/>
+          <p:cNvPr id="15" name="text-161"/>
           <p:cNvSpPr txBox="1"/>
           <p:nvPr/>
         </p:nvSpPr>
@@ -3792,7 +3792,7 @@
       </p:sp>
       <p:sp>
         <p:nvSpPr>
-          <p:cNvPr id="16" name="frame-164"/>
+          <p:cNvPr id="16" name="frame-162"/>
           <p:cNvSpPr/>
           <p:nvPr/>
         </p:nvSpPr>
@@ -3817,7 +3817,7 @@
       </p:sp>
       <p:sp>
         <p:nvSpPr>
-          <p:cNvPr id="17" name="text-165"/>
+          <p:cNvPr id="17" name="text-163"/>
           <p:cNvSpPr txBox="1"/>
           <p:nvPr/>
         </p:nvSpPr>
@@ -3856,7 +3856,7 @@
       </p:sp>
       <p:sp>
         <p:nvSpPr>
-          <p:cNvPr id="18" name="text-166"/>
+          <p:cNvPr id="18" name="text-164"/>
           <p:cNvSpPr txBox="1"/>
           <p:nvPr/>
         </p:nvSpPr>
@@ -3920,7 +3920,7 @@
       </p:sp>
       <p:sp>
         <p:nvSpPr>
-          <p:cNvPr id="19" name="frame-167"/>
+          <p:cNvPr id="19" name="frame-165"/>
           <p:cNvSpPr/>
           <p:nvPr/>
         </p:nvSpPr>
@@ -3945,7 +3945,7 @@
       </p:sp>
       <p:sp>
         <p:nvSpPr>
-          <p:cNvPr id="20" name="text-168"/>
+          <p:cNvPr id="20" name="text-166"/>
           <p:cNvSpPr txBox="1"/>
           <p:nvPr/>
         </p:nvSpPr>
@@ -3984,7 +3984,7 @@
       </p:sp>
       <p:sp>
         <p:nvSpPr>
-          <p:cNvPr id="21" name="text-169"/>
+          <p:cNvPr id="21" name="text-167"/>
           <p:cNvSpPr txBox="1"/>
           <p:nvPr/>
         </p:nvSpPr>
@@ -4048,7 +4048,7 @@
       </p:sp>
       <p:sp>
         <p:nvSpPr>
-          <p:cNvPr id="22" name="frame-170"/>
+          <p:cNvPr id="22" name="frame-168"/>
           <p:cNvSpPr/>
           <p:nvPr/>
         </p:nvSpPr>
@@ -4073,7 +4073,7 @@
       </p:sp>
       <p:sp>
         <p:nvSpPr>
-          <p:cNvPr id="23" name="text-171"/>
+          <p:cNvPr id="23" name="text-169"/>
           <p:cNvSpPr txBox="1"/>
           <p:nvPr/>
         </p:nvSpPr>
@@ -4112,7 +4112,7 @@
       </p:sp>
       <p:sp>
         <p:nvSpPr>
-          <p:cNvPr id="24" name="text-172"/>
+          <p:cNvPr id="24" name="text-170"/>
           <p:cNvSpPr txBox="1"/>
           <p:nvPr/>
         </p:nvSpPr>
@@ -4176,7 +4176,7 @@
       </p:sp>
       <p:sp>
         <p:nvSpPr>
-          <p:cNvPr id="25" name="card-173"/>
+          <p:cNvPr id="25" name="card-171"/>
           <p:cNvSpPr/>
           <p:nvPr/>
         </p:nvSpPr>
@@ -4201,7 +4201,7 @@
       </p:sp>
       <p:sp>
         <p:nvSpPr>
-          <p:cNvPr id="26" name="text-174"/>
+          <p:cNvPr id="26" name="text-172"/>
           <p:cNvSpPr txBox="1"/>
           <p:nvPr/>
         </p:nvSpPr>
@@ -4257,7 +4257,7 @@
       </p:sp>
       <p:sp>
         <p:nvSpPr>
-          <p:cNvPr id="27" name="card-175"/>
+          <p:cNvPr id="27" name="card-173"/>
           <p:cNvSpPr/>
           <p:nvPr/>
         </p:nvSpPr>
@@ -4282,7 +4282,7 @@
       </p:sp>
       <p:sp>
         <p:nvSpPr>
-          <p:cNvPr id="28" name="text-176"/>
+          <p:cNvPr id="28" name="text-174"/>
           <p:cNvSpPr txBox="1"/>
           <p:nvPr/>
         </p:nvSpPr>
@@ -10663,7 +10663,7 @@
         <p:spPr>
           <a:xfrm>
             <a:off x="8229600" y="1115568"/>
-            <a:ext cx="3547872" cy="4395969"/>
+            <a:ext cx="3547872" cy="4431771"/>
           </a:xfrm>
           <a:prstGeom prst="rect">
             <a:avLst/>
@@ -10679,7 +10679,7 @@
         <p:spPr>
           <a:xfrm>
             <a:off x="8229600" y="1115568"/>
-            <a:ext cx="3547872" cy="4395969"/>
+            <a:ext cx="3547872" cy="4431771"/>
           </a:xfrm>
           <a:prstGeom prst="rect">
             <a:avLst/>
@@ -10700,7 +10700,7 @@
         </p:nvSpPr>
         <p:spPr>
           <a:xfrm>
-            <a:off x="8229600" y="5566401"/>
+            <a:off x="8229600" y="5602203"/>
             <a:ext cx="3547872" cy="274320"/>
           </a:xfrm>
           <a:prstGeom prst="rect">
@@ -11345,7 +11345,7 @@
         <p:spPr>
           <a:xfrm>
             <a:off x="4114800" y="1115568"/>
-            <a:ext cx="7662672" cy="3054225"/>
+            <a:ext cx="7662672" cy="3317244"/>
           </a:xfrm>
           <a:prstGeom prst="rect">
             <a:avLst/>
@@ -11361,7 +11361,7 @@
         <p:spPr>
           <a:xfrm>
             <a:off x="4114800" y="1115568"/>
-            <a:ext cx="7662672" cy="3054225"/>
+            <a:ext cx="7662672" cy="3317244"/>
           </a:xfrm>
           <a:prstGeom prst="rect">
             <a:avLst/>
@@ -11382,7 +11382,7 @@
         </p:nvSpPr>
         <p:spPr>
           <a:xfrm>
-            <a:off x="4114800" y="4279521"/>
+            <a:off x="4114800" y="4524252"/>
             <a:ext cx="7662672" cy="457200"/>
           </a:xfrm>
           <a:prstGeom prst="rect">
@@ -11407,7 +11407,7 @@
                 <a:ea typeface="Arial" pitchFamily="34" charset="-122"/>
                 <a:cs typeface="Arial" pitchFamily="34" charset="-120"/>
               </a:rPr>
-              <a:t>Grey bar </a:t>
+              <a:t>Dark bar </a:t>
             </a:r>
             <a:pPr indent="0" marL="0">
               <a:buNone/>
@@ -11463,8 +11463,8 @@
         </p:nvSpPr>
         <p:spPr>
           <a:xfrm>
-            <a:off x="4114800" y="4892040"/>
-            <a:ext cx="7662672" cy="1325880"/>
+            <a:off x="4114800" y="5091180"/>
+            <a:ext cx="7662672" cy="1172460"/>
           </a:xfrm>
           <a:prstGeom prst="rect">
             <a:avLst/>
@@ -11488,8 +11488,8 @@
         </p:nvSpPr>
         <p:spPr>
           <a:xfrm>
-            <a:off x="4279392" y="4956048"/>
-            <a:ext cx="7315200" cy="1188720"/>
+            <a:off x="4279392" y="5136900"/>
+            <a:ext cx="7315200" cy="1081020"/>
           </a:xfrm>
           <a:prstGeom prst="rect">
             <a:avLst/>
@@ -11505,7 +11505,7 @@
               <a:buNone/>
             </a:pPr>
             <a:r>
-              <a:rPr lang="en-US" sz="1500" i="1" dirty="0">
+              <a:rPr lang="en-US" sz="1400" i="1" dirty="0">
                 <a:solidFill>
                   <a:schemeClr val="tx2"/>
                 </a:solidFill>
@@ -11515,7 +11515,7 @@
               </a:rPr>
               <a:t>Where a false negative can cost aircrew and a false positive wastes a sortie, a system that knows the limits of its own confidence is worth more than one that is slightly more accurate on average.</a:t>
             </a:r>
-            <a:endParaRPr lang="en-US" sz="1500" dirty="0"/>
+            <a:endParaRPr lang="en-US" sz="1400" dirty="0"/>
           </a:p>
         </p:txBody>
       </p:sp>
@@ -13644,7 +13644,7 @@
       </p:sp>
       <p:pic>
         <p:nvPicPr>
-          <p:cNvPr id="5" name="shot-143" descr="Attribution waterfall, current practice">    </p:cNvPr>
+          <p:cNvPr id="5" name="shot-143" descr="Attribution waterfall under current practice">    </p:cNvPr>
           <p:cNvPicPr>
             <a:picLocks noChangeAspect="1"/>
           </p:cNvPicPr>
@@ -13659,7 +13659,7 @@
         <p:spPr>
           <a:xfrm>
             <a:off x="411480" y="1600200"/>
-            <a:ext cx="4663440" cy="3049458"/>
+            <a:ext cx="5669280" cy="4491248"/>
           </a:xfrm>
           <a:prstGeom prst="rect">
             <a:avLst/>
@@ -13675,7 +13675,7 @@
         <p:spPr>
           <a:xfrm>
             <a:off x="411480" y="1600200"/>
-            <a:ext cx="4663440" cy="3049458"/>
+            <a:ext cx="5669280" cy="4491248"/>
           </a:xfrm>
           <a:prstGeom prst="rect">
             <a:avLst/>
@@ -13688,94 +13688,9 @@
           </a:ln>
         </p:spPr>
       </p:sp>
-      <p:pic>
-        <p:nvPicPr>
-          <p:cNvPr id="7" name="shot-145" descr="Line board: every aircraft, every day, coloured by reason">    </p:cNvPr>
-          <p:cNvPicPr>
-            <a:picLocks noChangeAspect="1"/>
-          </p:cNvPicPr>
-          <p:nvPr/>
-        </p:nvPicPr>
-        <p:blipFill>
-          <a:blip r:embed="rId2"/>
-          <a:stretch>
-            <a:fillRect/>
-          </a:stretch>
-        </p:blipFill>
-        <p:spPr>
-          <a:xfrm>
-            <a:off x="5303520" y="1600200"/>
-            <a:ext cx="6473952" cy="3303141"/>
-          </a:xfrm>
-          <a:prstGeom prst="rect">
-            <a:avLst/>
-          </a:prstGeom>
-        </p:spPr>
-      </p:pic>
-      <p:sp>
-        <p:nvSpPr>
-          <p:cNvPr id="8" name="shot-frame-146"/>
-          <p:cNvSpPr/>
-          <p:nvPr/>
-        </p:nvSpPr>
-        <p:spPr>
-          <a:xfrm>
-            <a:off x="5303520" y="1600200"/>
-            <a:ext cx="6473952" cy="3303141"/>
-          </a:xfrm>
-          <a:prstGeom prst="rect">
-            <a:avLst/>
-          </a:prstGeom>
-          <a:ln w="9525">
-            <a:solidFill>
-              <a:srgbClr val="9AA6B1"/>
-            </a:solidFill>
-            <a:prstDash val="solid"/>
-          </a:ln>
-        </p:spPr>
-      </p:sp>
-      <p:sp>
-        <p:nvSpPr>
-          <p:cNvPr id="9" name="text-147"/>
-          <p:cNvSpPr txBox="1"/>
-          <p:nvPr/>
-        </p:nvSpPr>
-        <p:spPr>
-          <a:xfrm>
-            <a:off x="5303520" y="4958205"/>
-            <a:ext cx="6473952" cy="274320"/>
-          </a:xfrm>
-          <a:prstGeom prst="rect">
-            <a:avLst/>
-          </a:prstGeom>
-          <a:noFill/>
-          <a:ln/>
-        </p:spPr>
-        <p:txBody>
-          <a:bodyPr wrap="square" lIns="0" tIns="0" rIns="0" bIns="0" rtlCol="0" anchor="t"/>
-          <a:lstStyle/>
-          <a:p>
-            <a:pPr indent="0" marL="0">
-              <a:buNone/>
-            </a:pPr>
-            <a:r>
-              <a:rPr lang="en-US" sz="1000" dirty="0">
-                <a:solidFill>
-                  <a:srgbClr val="6B7780"/>
-                </a:solidFill>
-                <a:latin typeface="Arial" pitchFamily="34" charset="0"/>
-                <a:ea typeface="Arial" pitchFamily="34" charset="-122"/>
-                <a:cs typeface="Arial" pitchFamily="34" charset="-120"/>
-              </a:rPr>
-              <a:t>Line board: 24 aircraft × 90 days, each day on the ground coloured by its reason (current practice)</a:t>
-            </a:r>
-            <a:endParaRPr lang="en-US" sz="1000" dirty="0"/>
-          </a:p>
-        </p:txBody>
-      </p:sp>
       <p:graphicFrame>
         <p:nvGraphicFramePr>
-          <p:cNvPr id="10" name="attr-table-148"/>
+          <p:cNvPr id="10" name="attr-table-145"/>
           <p:cNvGraphicFramePr>
             <a:graphicFrameLocks noGrp="1"/>
           </p:cNvGraphicFramePr>
@@ -13788,19 +13703,19 @@
           </p:nvPr>
         </p:nvGraphicFramePr>
         <p:xfrm>
-          <a:off x="411480" y="4814250"/>
-          <a:ext cx="4663440" cy="914400"/>
+          <a:off x="6355080" y="1600200"/>
+          <a:ext cx="5422392" cy="914400"/>
         </p:xfrm>
         <a:graphic>
           <a:graphicData uri="http://schemas.openxmlformats.org/drawingml/2006/table">
             <a:tbl>
               <a:tblPr/>
               <a:tblGrid>
-                <a:gridCol w="2103120"/>
-                <a:gridCol w="1005840"/>
-                <a:gridCol w="1554480"/>
+                <a:gridCol w="2862072"/>
+                <a:gridCol w="1280160"/>
+                <a:gridCol w="1280160"/>
               </a:tblGrid>
-              <a:tr h="274320">
+              <a:tr h="384048">
                 <a:tc>
                   <a:txBody>
                     <a:bodyPr/>
@@ -13810,7 +13725,213 @@
                         <a:buNone/>
                       </a:pPr>
                       <a:r>
-                        <a:rPr lang="en-US" sz="1150" dirty="0">
+                        <a:rPr lang="en-US" sz="1300" b="1" dirty="0">
+                          <a:solidFill>
+                            <a:srgbClr val="FFFFFF"/>
+                          </a:solidFill>
+                          <a:latin typeface="Arial" pitchFamily="34" charset="0"/>
+                          <a:ea typeface="Arial" pitchFamily="34" charset="-122"/>
+                          <a:cs typeface="Arial" pitchFamily="34" charset="-120"/>
+                        </a:rPr>
+                        <a:t>Cause</a:t>
+                      </a:r>
+                      <a:endParaRPr lang="en-US" sz="1300" dirty="0">
+                        <a:latin typeface="Arial" charset="0"/>
+                        <a:ea typeface="Arial" charset="0"/>
+                        <a:cs typeface="Arial" charset="0"/>
+                      </a:endParaRPr>
+                    </a:p>
+                  </a:txBody>
+                  <a:tcPr marL="101600" marR="101600" marT="25400" marB="25400" anchor="ctr">
+                    <a:lnL w="6350" cap="flat" cmpd="sng" algn="ctr">
+                      <a:solidFill>
+                        <a:srgbClr val="C9D3DD"/>
+                      </a:solidFill>
+                      <a:prstDash val="solid"/>
+                      <a:round/>
+                      <a:headEnd type="none" w="med" len="med"/>
+                      <a:tailEnd type="none" w="med" len="med"/>
+                    </a:lnL>
+                    <a:lnR w="6350" cap="flat" cmpd="sng" algn="ctr">
+                      <a:solidFill>
+                        <a:srgbClr val="C9D3DD"/>
+                      </a:solidFill>
+                      <a:prstDash val="solid"/>
+                      <a:round/>
+                      <a:headEnd type="none" w="med" len="med"/>
+                      <a:tailEnd type="none" w="med" len="med"/>
+                    </a:lnR>
+                    <a:lnT w="6350" cap="flat" cmpd="sng" algn="ctr">
+                      <a:solidFill>
+                        <a:srgbClr val="C9D3DD"/>
+                      </a:solidFill>
+                      <a:prstDash val="solid"/>
+                      <a:round/>
+                      <a:headEnd type="none" w="med" len="med"/>
+                      <a:tailEnd type="none" w="med" len="med"/>
+                    </a:lnT>
+                    <a:lnB w="6350" cap="flat" cmpd="sng" algn="ctr">
+                      <a:solidFill>
+                        <a:srgbClr val="C9D3DD"/>
+                      </a:solidFill>
+                      <a:prstDash val="solid"/>
+                      <a:round/>
+                      <a:headEnd type="none" w="med" len="med"/>
+                      <a:tailEnd type="none" w="med" len="med"/>
+                    </a:lnB>
+                    <a:solidFill>
+                      <a:srgbClr val="1F3A5F"/>
+                    </a:solidFill>
+                  </a:tcPr>
+                </a:tc>
+                <a:tc>
+                  <a:txBody>
+                    <a:bodyPr/>
+                    <a:lstStyle/>
+                    <a:p>
+                      <a:pPr algn="r" indent="0" marL="0">
+                        <a:buNone/>
+                      </a:pPr>
+                      <a:r>
+                        <a:rPr lang="en-US" sz="1300" b="1" dirty="0">
+                          <a:solidFill>
+                            <a:srgbClr val="FFFFFF"/>
+                          </a:solidFill>
+                          <a:latin typeface="Arial" pitchFamily="34" charset="0"/>
+                          <a:ea typeface="Arial" pitchFamily="34" charset="-122"/>
+                          <a:cs typeface="Arial" pitchFamily="34" charset="-120"/>
+                        </a:rPr>
+                        <a:t>Points of Ao</a:t>
+                      </a:r>
+                      <a:endParaRPr lang="en-US" sz="1300" dirty="0">
+                        <a:latin typeface="Arial" charset="0"/>
+                        <a:ea typeface="Arial" charset="0"/>
+                        <a:cs typeface="Arial" charset="0"/>
+                      </a:endParaRPr>
+                    </a:p>
+                  </a:txBody>
+                  <a:tcPr marL="101600" marR="101600" marT="25400" marB="25400" anchor="ctr">
+                    <a:lnL w="6350" cap="flat" cmpd="sng" algn="ctr">
+                      <a:solidFill>
+                        <a:srgbClr val="C9D3DD"/>
+                      </a:solidFill>
+                      <a:prstDash val="solid"/>
+                      <a:round/>
+                      <a:headEnd type="none" w="med" len="med"/>
+                      <a:tailEnd type="none" w="med" len="med"/>
+                    </a:lnL>
+                    <a:lnR w="6350" cap="flat" cmpd="sng" algn="ctr">
+                      <a:solidFill>
+                        <a:srgbClr val="C9D3DD"/>
+                      </a:solidFill>
+                      <a:prstDash val="solid"/>
+                      <a:round/>
+                      <a:headEnd type="none" w="med" len="med"/>
+                      <a:tailEnd type="none" w="med" len="med"/>
+                    </a:lnR>
+                    <a:lnT w="6350" cap="flat" cmpd="sng" algn="ctr">
+                      <a:solidFill>
+                        <a:srgbClr val="C9D3DD"/>
+                      </a:solidFill>
+                      <a:prstDash val="solid"/>
+                      <a:round/>
+                      <a:headEnd type="none" w="med" len="med"/>
+                      <a:tailEnd type="none" w="med" len="med"/>
+                    </a:lnT>
+                    <a:lnB w="6350" cap="flat" cmpd="sng" algn="ctr">
+                      <a:solidFill>
+                        <a:srgbClr val="C9D3DD"/>
+                      </a:solidFill>
+                      <a:prstDash val="solid"/>
+                      <a:round/>
+                      <a:headEnd type="none" w="med" len="med"/>
+                      <a:tailEnd type="none" w="med" len="med"/>
+                    </a:lnB>
+                    <a:solidFill>
+                      <a:srgbClr val="1F3A5F"/>
+                    </a:solidFill>
+                  </a:tcPr>
+                </a:tc>
+                <a:tc>
+                  <a:txBody>
+                    <a:bodyPr/>
+                    <a:lstStyle/>
+                    <a:p>
+                      <a:pPr algn="r" indent="0" marL="0">
+                        <a:buNone/>
+                      </a:pPr>
+                      <a:r>
+                        <a:rPr lang="en-US" sz="1300" b="1" dirty="0">
+                          <a:solidFill>
+                            <a:srgbClr val="FFFFFF"/>
+                          </a:solidFill>
+                          <a:latin typeface="Arial" pitchFamily="34" charset="0"/>
+                          <a:ea typeface="Arial" pitchFamily="34" charset="-122"/>
+                          <a:cs typeface="Arial" pitchFamily="34" charset="-120"/>
+                        </a:rPr>
+                        <a:t>Aircraft-days</a:t>
+                      </a:r>
+                      <a:endParaRPr lang="en-US" sz="1300" dirty="0">
+                        <a:latin typeface="Arial" charset="0"/>
+                        <a:ea typeface="Arial" charset="0"/>
+                        <a:cs typeface="Arial" charset="0"/>
+                      </a:endParaRPr>
+                    </a:p>
+                  </a:txBody>
+                  <a:tcPr marL="101600" marR="101600" marT="25400" marB="25400" anchor="ctr">
+                    <a:lnL w="6350" cap="flat" cmpd="sng" algn="ctr">
+                      <a:solidFill>
+                        <a:srgbClr val="C9D3DD"/>
+                      </a:solidFill>
+                      <a:prstDash val="solid"/>
+                      <a:round/>
+                      <a:headEnd type="none" w="med" len="med"/>
+                      <a:tailEnd type="none" w="med" len="med"/>
+                    </a:lnL>
+                    <a:lnR w="6350" cap="flat" cmpd="sng" algn="ctr">
+                      <a:solidFill>
+                        <a:srgbClr val="C9D3DD"/>
+                      </a:solidFill>
+                      <a:prstDash val="solid"/>
+                      <a:round/>
+                      <a:headEnd type="none" w="med" len="med"/>
+                      <a:tailEnd type="none" w="med" len="med"/>
+                    </a:lnR>
+                    <a:lnT w="6350" cap="flat" cmpd="sng" algn="ctr">
+                      <a:solidFill>
+                        <a:srgbClr val="C9D3DD"/>
+                      </a:solidFill>
+                      <a:prstDash val="solid"/>
+                      <a:round/>
+                      <a:headEnd type="none" w="med" len="med"/>
+                      <a:tailEnd type="none" w="med" len="med"/>
+                    </a:lnT>
+                    <a:lnB w="6350" cap="flat" cmpd="sng" algn="ctr">
+                      <a:solidFill>
+                        <a:srgbClr val="C9D3DD"/>
+                      </a:solidFill>
+                      <a:prstDash val="solid"/>
+                      <a:round/>
+                      <a:headEnd type="none" w="med" len="med"/>
+                      <a:tailEnd type="none" w="med" len="med"/>
+                    </a:lnB>
+                    <a:solidFill>
+                      <a:srgbClr val="1F3A5F"/>
+                    </a:solidFill>
+                  </a:tcPr>
+                </a:tc>
+              </a:tr>
+              <a:tr h="384048">
+                <a:tc>
+                  <a:txBody>
+                    <a:bodyPr/>
+                    <a:lstStyle/>
+                    <a:p>
+                      <a:pPr indent="0" marL="0">
+                        <a:buNone/>
+                      </a:pPr>
+                      <a:r>
+                        <a:rPr lang="en-US" sz="1300" dirty="0">
                           <a:solidFill>
                             <a:srgbClr val="000000"/>
                           </a:solidFill>
@@ -13820,14 +13941,14 @@
                         </a:rPr>
                         <a:t>Waiting for spares</a:t>
                       </a:r>
-                      <a:endParaRPr lang="en-US" sz="1150" dirty="0">
+                      <a:endParaRPr lang="en-US" sz="1300" dirty="0">
                         <a:latin typeface="Arial" charset="0"/>
                         <a:ea typeface="Arial" charset="0"/>
                         <a:cs typeface="Arial" charset="0"/>
                       </a:endParaRPr>
                     </a:p>
                   </a:txBody>
-                  <a:tcPr marL="63500" marR="63500" marT="12700" marB="12700" anchor="ctr">
+                  <a:tcPr marL="101600" marR="101600" marT="25400" marB="25400" anchor="ctr">
                     <a:lnL w="6350" cap="flat" cmpd="sng" algn="ctr">
                       <a:solidFill>
                         <a:srgbClr val="C9D3DD"/>
@@ -13875,7 +13996,7 @@
                         <a:buNone/>
                       </a:pPr>
                       <a:r>
-                        <a:rPr lang="en-US" sz="1150" b="1" dirty="0">
+                        <a:rPr lang="en-US" sz="1300" b="1" dirty="0">
                           <a:solidFill>
                             <a:srgbClr val="000000"/>
                           </a:solidFill>
@@ -13883,16 +14004,16 @@
                           <a:ea typeface="Arial" pitchFamily="34" charset="-122"/>
                           <a:cs typeface="Arial" pitchFamily="34" charset="-120"/>
                         </a:rPr>
-                        <a:t>8.0 pts</a:t>
+                        <a:t>8.0</a:t>
                       </a:r>
-                      <a:endParaRPr lang="en-US" sz="1150" dirty="0">
+                      <a:endParaRPr lang="en-US" sz="1300" dirty="0">
                         <a:latin typeface="Arial" charset="0"/>
                         <a:ea typeface="Arial" charset="0"/>
                         <a:cs typeface="Arial" charset="0"/>
                       </a:endParaRPr>
                     </a:p>
                   </a:txBody>
-                  <a:tcPr marL="63500" marR="63500" marT="12700" marB="12700" anchor="ctr">
+                  <a:tcPr marL="101600" marR="101600" marT="25400" marB="25400" anchor="ctr">
                     <a:lnL w="6350" cap="flat" cmpd="sng" algn="ctr">
                       <a:solidFill>
                         <a:srgbClr val="C9D3DD"/>
@@ -13940,7 +14061,7 @@
                         <a:buNone/>
                       </a:pPr>
                       <a:r>
-                        <a:rPr lang="en-US" sz="1150" dirty="0">
+                        <a:rPr lang="en-US" sz="1300" dirty="0">
                           <a:solidFill>
                             <a:srgbClr val="444444"/>
                           </a:solidFill>
@@ -13948,16 +14069,16 @@
                           <a:ea typeface="Arial" pitchFamily="34" charset="-122"/>
                           <a:cs typeface="Arial" pitchFamily="34" charset="-120"/>
                         </a:rPr>
-                        <a:t>173 aircraft-days</a:t>
+                        <a:t>173</a:t>
                       </a:r>
-                      <a:endParaRPr lang="en-US" sz="1150" dirty="0">
+                      <a:endParaRPr lang="en-US" sz="1300" dirty="0">
                         <a:latin typeface="Arial" charset="0"/>
                         <a:ea typeface="Arial" charset="0"/>
                         <a:cs typeface="Arial" charset="0"/>
                       </a:endParaRPr>
                     </a:p>
                   </a:txBody>
-                  <a:tcPr marL="63500" marR="63500" marT="12700" marB="12700" anchor="ctr">
+                  <a:tcPr marL="101600" marR="101600" marT="25400" marB="25400" anchor="ctr">
                     <a:lnL w="6350" cap="flat" cmpd="sng" algn="ctr">
                       <a:solidFill>
                         <a:srgbClr val="C9D3DD"/>
@@ -13997,7 +14118,7 @@
                   </a:tcPr>
                 </a:tc>
               </a:tr>
-              <a:tr h="274320">
+              <a:tr h="384048">
                 <a:tc>
                   <a:txBody>
                     <a:bodyPr/>
@@ -14007,7 +14128,7 @@
                         <a:buNone/>
                       </a:pPr>
                       <a:r>
-                        <a:rPr lang="en-US" sz="1150" dirty="0">
+                        <a:rPr lang="en-US" sz="1300" dirty="0">
                           <a:solidFill>
                             <a:srgbClr val="000000"/>
                           </a:solidFill>
@@ -14017,14 +14138,14 @@
                         </a:rPr>
                         <a:t>Waiting for a depot bay</a:t>
                       </a:r>
-                      <a:endParaRPr lang="en-US" sz="1150" dirty="0">
+                      <a:endParaRPr lang="en-US" sz="1300" dirty="0">
                         <a:latin typeface="Arial" charset="0"/>
                         <a:ea typeface="Arial" charset="0"/>
                         <a:cs typeface="Arial" charset="0"/>
                       </a:endParaRPr>
                     </a:p>
                   </a:txBody>
-                  <a:tcPr marL="63500" marR="63500" marT="12700" marB="12700" anchor="ctr">
+                  <a:tcPr marL="101600" marR="101600" marT="25400" marB="25400" anchor="ctr">
                     <a:lnL w="6350" cap="flat" cmpd="sng" algn="ctr">
                       <a:solidFill>
                         <a:srgbClr val="C9D3DD"/>
@@ -14072,7 +14193,7 @@
                         <a:buNone/>
                       </a:pPr>
                       <a:r>
-                        <a:rPr lang="en-US" sz="1150" b="1" dirty="0">
+                        <a:rPr lang="en-US" sz="1300" b="1" dirty="0">
                           <a:solidFill>
                             <a:srgbClr val="000000"/>
                           </a:solidFill>
@@ -14080,16 +14201,16 @@
                           <a:ea typeface="Arial" pitchFamily="34" charset="-122"/>
                           <a:cs typeface="Arial" pitchFamily="34" charset="-120"/>
                         </a:rPr>
-                        <a:t>1.3 pts</a:t>
+                        <a:t>1.3</a:t>
                       </a:r>
-                      <a:endParaRPr lang="en-US" sz="1150" dirty="0">
+                      <a:endParaRPr lang="en-US" sz="1300" dirty="0">
                         <a:latin typeface="Arial" charset="0"/>
                         <a:ea typeface="Arial" charset="0"/>
                         <a:cs typeface="Arial" charset="0"/>
                       </a:endParaRPr>
                     </a:p>
                   </a:txBody>
-                  <a:tcPr marL="63500" marR="63500" marT="12700" marB="12700" anchor="ctr">
+                  <a:tcPr marL="101600" marR="101600" marT="25400" marB="25400" anchor="ctr">
                     <a:lnL w="6350" cap="flat" cmpd="sng" algn="ctr">
                       <a:solidFill>
                         <a:srgbClr val="C9D3DD"/>
@@ -14137,7 +14258,7 @@
                         <a:buNone/>
                       </a:pPr>
                       <a:r>
-                        <a:rPr lang="en-US" sz="1150" dirty="0">
+                        <a:rPr lang="en-US" sz="1300" dirty="0">
                           <a:solidFill>
                             <a:srgbClr val="444444"/>
                           </a:solidFill>
@@ -14145,16 +14266,16 @@
                           <a:ea typeface="Arial" pitchFamily="34" charset="-122"/>
                           <a:cs typeface="Arial" pitchFamily="34" charset="-120"/>
                         </a:rPr>
-                        <a:t>27 aircraft-days</a:t>
+                        <a:t>27</a:t>
                       </a:r>
-                      <a:endParaRPr lang="en-US" sz="1150" dirty="0">
+                      <a:endParaRPr lang="en-US" sz="1300" dirty="0">
                         <a:latin typeface="Arial" charset="0"/>
                         <a:ea typeface="Arial" charset="0"/>
                         <a:cs typeface="Arial" charset="0"/>
                       </a:endParaRPr>
                     </a:p>
                   </a:txBody>
-                  <a:tcPr marL="63500" marR="63500" marT="12700" marB="12700" anchor="ctr">
+                  <a:tcPr marL="101600" marR="101600" marT="25400" marB="25400" anchor="ctr">
                     <a:lnL w="6350" cap="flat" cmpd="sng" algn="ctr">
                       <a:solidFill>
                         <a:srgbClr val="C9D3DD"/>
@@ -14194,7 +14315,7 @@
                   </a:tcPr>
                 </a:tc>
               </a:tr>
-              <a:tr h="274320">
+              <a:tr h="384048">
                 <a:tc>
                   <a:txBody>
                     <a:bodyPr/>
@@ -14204,7 +14325,7 @@
                         <a:buNone/>
                       </a:pPr>
                       <a:r>
-                        <a:rPr lang="en-US" sz="1150" dirty="0">
+                        <a:rPr lang="en-US" sz="1300" dirty="0">
                           <a:solidFill>
                             <a:srgbClr val="000000"/>
                           </a:solidFill>
@@ -14214,14 +14335,14 @@
                         </a:rPr>
                         <a:t>Unscheduled removal</a:t>
                       </a:r>
-                      <a:endParaRPr lang="en-US" sz="1150" dirty="0">
+                      <a:endParaRPr lang="en-US" sz="1300" dirty="0">
                         <a:latin typeface="Arial" charset="0"/>
                         <a:ea typeface="Arial" charset="0"/>
                         <a:cs typeface="Arial" charset="0"/>
                       </a:endParaRPr>
                     </a:p>
                   </a:txBody>
-                  <a:tcPr marL="63500" marR="63500" marT="12700" marB="12700" anchor="ctr">
+                  <a:tcPr marL="101600" marR="101600" marT="25400" marB="25400" anchor="ctr">
                     <a:lnL w="6350" cap="flat" cmpd="sng" algn="ctr">
                       <a:solidFill>
                         <a:srgbClr val="C9D3DD"/>
@@ -14269,7 +14390,7 @@
                         <a:buNone/>
                       </a:pPr>
                       <a:r>
-                        <a:rPr lang="en-US" sz="1150" b="1" dirty="0">
+                        <a:rPr lang="en-US" sz="1300" b="1" dirty="0">
                           <a:solidFill>
                             <a:srgbClr val="000000"/>
                           </a:solidFill>
@@ -14277,16 +14398,16 @@
                           <a:ea typeface="Arial" pitchFamily="34" charset="-122"/>
                           <a:cs typeface="Arial" pitchFamily="34" charset="-120"/>
                         </a:rPr>
-                        <a:t>1.6 pts</a:t>
+                        <a:t>1.6</a:t>
                       </a:r>
-                      <a:endParaRPr lang="en-US" sz="1150" dirty="0">
+                      <a:endParaRPr lang="en-US" sz="1300" dirty="0">
                         <a:latin typeface="Arial" charset="0"/>
                         <a:ea typeface="Arial" charset="0"/>
                         <a:cs typeface="Arial" charset="0"/>
                       </a:endParaRPr>
                     </a:p>
                   </a:txBody>
-                  <a:tcPr marL="63500" marR="63500" marT="12700" marB="12700" anchor="ctr">
+                  <a:tcPr marL="101600" marR="101600" marT="25400" marB="25400" anchor="ctr">
                     <a:lnL w="6350" cap="flat" cmpd="sng" algn="ctr">
                       <a:solidFill>
                         <a:srgbClr val="C9D3DD"/>
@@ -14334,7 +14455,7 @@
                         <a:buNone/>
                       </a:pPr>
                       <a:r>
-                        <a:rPr lang="en-US" sz="1150" dirty="0">
+                        <a:rPr lang="en-US" sz="1300" dirty="0">
                           <a:solidFill>
                             <a:srgbClr val="444444"/>
                           </a:solidFill>
@@ -14342,16 +14463,16 @@
                           <a:ea typeface="Arial" pitchFamily="34" charset="-122"/>
                           <a:cs typeface="Arial" pitchFamily="34" charset="-120"/>
                         </a:rPr>
-                        <a:t>34 aircraft-days</a:t>
+                        <a:t>34</a:t>
                       </a:r>
-                      <a:endParaRPr lang="en-US" sz="1150" dirty="0">
+                      <a:endParaRPr lang="en-US" sz="1300" dirty="0">
                         <a:latin typeface="Arial" charset="0"/>
                         <a:ea typeface="Arial" charset="0"/>
                         <a:cs typeface="Arial" charset="0"/>
                       </a:endParaRPr>
                     </a:p>
                   </a:txBody>
-                  <a:tcPr marL="63500" marR="63500" marT="12700" marB="12700" anchor="ctr">
+                  <a:tcPr marL="101600" marR="101600" marT="25400" marB="25400" anchor="ctr">
                     <a:lnL w="6350" cap="flat" cmpd="sng" algn="ctr">
                       <a:solidFill>
                         <a:srgbClr val="C9D3DD"/>
@@ -14391,7 +14512,7 @@
                   </a:tcPr>
                 </a:tc>
               </a:tr>
-              <a:tr h="274320">
+              <a:tr h="384048">
                 <a:tc>
                   <a:txBody>
                     <a:bodyPr/>
@@ -14401,7 +14522,7 @@
                         <a:buNone/>
                       </a:pPr>
                       <a:r>
-                        <a:rPr lang="en-US" sz="1150" dirty="0">
+                        <a:rPr lang="en-US" sz="1300" dirty="0">
                           <a:solidFill>
                             <a:srgbClr val="000000"/>
                           </a:solidFill>
@@ -14411,14 +14532,14 @@
                         </a:rPr>
                         <a:t>Cannibalisation cascade</a:t>
                       </a:r>
-                      <a:endParaRPr lang="en-US" sz="1150" dirty="0">
+                      <a:endParaRPr lang="en-US" sz="1300" dirty="0">
                         <a:latin typeface="Arial" charset="0"/>
                         <a:ea typeface="Arial" charset="0"/>
                         <a:cs typeface="Arial" charset="0"/>
                       </a:endParaRPr>
                     </a:p>
                   </a:txBody>
-                  <a:tcPr marL="63500" marR="63500" marT="12700" marB="12700" anchor="ctr">
+                  <a:tcPr marL="101600" marR="101600" marT="25400" marB="25400" anchor="ctr">
                     <a:lnL w="6350" cap="flat" cmpd="sng" algn="ctr">
                       <a:solidFill>
                         <a:srgbClr val="C9D3DD"/>
@@ -14466,7 +14587,7 @@
                         <a:buNone/>
                       </a:pPr>
                       <a:r>
-                        <a:rPr lang="en-US" sz="1150" b="1" dirty="0">
+                        <a:rPr lang="en-US" sz="1300" b="1" dirty="0">
                           <a:solidFill>
                             <a:srgbClr val="000000"/>
                           </a:solidFill>
@@ -14474,16 +14595,16 @@
                           <a:ea typeface="Arial" pitchFamily="34" charset="-122"/>
                           <a:cs typeface="Arial" pitchFamily="34" charset="-120"/>
                         </a:rPr>
-                        <a:t>0.1 pts</a:t>
+                        <a:t>0.1</a:t>
                       </a:r>
-                      <a:endParaRPr lang="en-US" sz="1150" dirty="0">
+                      <a:endParaRPr lang="en-US" sz="1300" dirty="0">
                         <a:latin typeface="Arial" charset="0"/>
                         <a:ea typeface="Arial" charset="0"/>
                         <a:cs typeface="Arial" charset="0"/>
                       </a:endParaRPr>
                     </a:p>
                   </a:txBody>
-                  <a:tcPr marL="63500" marR="63500" marT="12700" marB="12700" anchor="ctr">
+                  <a:tcPr marL="101600" marR="101600" marT="25400" marB="25400" anchor="ctr">
                     <a:lnL w="6350" cap="flat" cmpd="sng" algn="ctr">
                       <a:solidFill>
                         <a:srgbClr val="C9D3DD"/>
@@ -14531,7 +14652,7 @@
                         <a:buNone/>
                       </a:pPr>
                       <a:r>
-                        <a:rPr lang="en-US" sz="1150" dirty="0">
+                        <a:rPr lang="en-US" sz="1300" dirty="0">
                           <a:solidFill>
                             <a:srgbClr val="444444"/>
                           </a:solidFill>
@@ -14539,16 +14660,16 @@
                           <a:ea typeface="Arial" pitchFamily="34" charset="-122"/>
                           <a:cs typeface="Arial" pitchFamily="34" charset="-120"/>
                         </a:rPr>
-                        <a:t>3 aircraft-days</a:t>
+                        <a:t>3</a:t>
                       </a:r>
-                      <a:endParaRPr lang="en-US" sz="1150" dirty="0">
+                      <a:endParaRPr lang="en-US" sz="1300" dirty="0">
                         <a:latin typeface="Arial" charset="0"/>
                         <a:ea typeface="Arial" charset="0"/>
                         <a:cs typeface="Arial" charset="0"/>
                       </a:endParaRPr>
                     </a:p>
                   </a:txBody>
-                  <a:tcPr marL="63500" marR="63500" marT="12700" marB="12700" anchor="ctr">
+                  <a:tcPr marL="101600" marR="101600" marT="25400" marB="25400" anchor="ctr">
                     <a:lnL w="6350" cap="flat" cmpd="sng" algn="ctr">
                       <a:solidFill>
                         <a:srgbClr val="C9D3DD"/>
@@ -14588,7 +14709,7 @@
                   </a:tcPr>
                 </a:tc>
               </a:tr>
-              <a:tr h="274320">
+              <a:tr h="384048">
                 <a:tc>
                   <a:txBody>
                     <a:bodyPr/>
@@ -14598,7 +14719,7 @@
                         <a:buNone/>
                       </a:pPr>
                       <a:r>
-                        <a:rPr lang="en-US" sz="1150" b="1" dirty="0">
+                        <a:rPr lang="en-US" sz="1300" b="1" dirty="0">
                           <a:solidFill>
                             <a:srgbClr val="000000"/>
                           </a:solidFill>
@@ -14606,16 +14727,16 @@
                           <a:ea typeface="Arial" pitchFamily="34" charset="-122"/>
                           <a:cs typeface="Arial" pitchFamily="34" charset="-120"/>
                         </a:rPr>
-                        <a:t>Total availability gap</a:t>
+                        <a:t>Total gap below the ceiling</a:t>
                       </a:r>
-                      <a:endParaRPr lang="en-US" sz="1150" dirty="0">
+                      <a:endParaRPr lang="en-US" sz="1300" dirty="0">
                         <a:latin typeface="Arial" charset="0"/>
                         <a:ea typeface="Arial" charset="0"/>
                         <a:cs typeface="Arial" charset="0"/>
                       </a:endParaRPr>
                     </a:p>
                   </a:txBody>
-                  <a:tcPr marL="63500" marR="63500" marT="12700" marB="12700" anchor="ctr">
+                  <a:tcPr marL="101600" marR="101600" marT="25400" marB="25400" anchor="ctr">
                     <a:lnL w="6350" cap="flat" cmpd="sng" algn="ctr">
                       <a:solidFill>
                         <a:srgbClr val="C9D3DD"/>
@@ -14663,7 +14784,7 @@
                         <a:buNone/>
                       </a:pPr>
                       <a:r>
-                        <a:rPr lang="en-US" sz="1150" b="1" dirty="0">
+                        <a:rPr lang="en-US" sz="1300" b="1" dirty="0">
                           <a:solidFill>
                             <a:schemeClr val="accent1"/>
                           </a:solidFill>
@@ -14671,16 +14792,16 @@
                           <a:ea typeface="Arial" pitchFamily="34" charset="-122"/>
                           <a:cs typeface="Arial" pitchFamily="34" charset="-120"/>
                         </a:rPr>
-                        <a:t>11.0 pts</a:t>
+                        <a:t>11.0</a:t>
                       </a:r>
-                      <a:endParaRPr lang="en-US" sz="1150" dirty="0">
+                      <a:endParaRPr lang="en-US" sz="1300" dirty="0">
                         <a:latin typeface="Arial" charset="0"/>
                         <a:ea typeface="Arial" charset="0"/>
                         <a:cs typeface="Arial" charset="0"/>
                       </a:endParaRPr>
                     </a:p>
                   </a:txBody>
-                  <a:tcPr marL="63500" marR="63500" marT="12700" marB="12700" anchor="ctr">
+                  <a:tcPr marL="101600" marR="101600" marT="25400" marB="25400" anchor="ctr">
                     <a:lnL w="6350" cap="flat" cmpd="sng" algn="ctr">
                       <a:solidFill>
                         <a:srgbClr val="C9D3DD"/>
@@ -14728,7 +14849,7 @@
                         <a:buNone/>
                       </a:pPr>
                       <a:r>
-                        <a:rPr lang="en-US" sz="1150" b="1" dirty="0">
+                        <a:rPr lang="en-US" sz="1300" b="1" dirty="0">
                           <a:solidFill>
                             <a:srgbClr val="000000"/>
                           </a:solidFill>
@@ -14736,16 +14857,16 @@
                           <a:ea typeface="Arial" pitchFamily="34" charset="-122"/>
                           <a:cs typeface="Arial" pitchFamily="34" charset="-120"/>
                         </a:rPr>
-                        <a:t>237 aircraft-days</a:t>
+                        <a:t>237</a:t>
                       </a:r>
-                      <a:endParaRPr lang="en-US" sz="1150" dirty="0">
+                      <a:endParaRPr lang="en-US" sz="1300" dirty="0">
                         <a:latin typeface="Arial" charset="0"/>
                         <a:ea typeface="Arial" charset="0"/>
                         <a:cs typeface="Arial" charset="0"/>
                       </a:endParaRPr>
                     </a:p>
                   </a:txBody>
-                  <a:tcPr marL="63500" marR="63500" marT="12700" marB="12700" anchor="ctr">
+                  <a:tcPr marL="101600" marR="101600" marT="25400" marB="25400" anchor="ctr">
                     <a:lnL w="6350" cap="flat" cmpd="sng" algn="ctr">
                       <a:solidFill>
                         <a:srgbClr val="C9D3DD"/>
@@ -14791,14 +14912,14 @@
       </p:graphicFrame>
       <p:sp>
         <p:nvSpPr>
-          <p:cNvPr id="11" name="card-149"/>
+          <p:cNvPr id="8" name="card-146"/>
           <p:cNvSpPr/>
           <p:nvPr/>
         </p:nvSpPr>
         <p:spPr>
           <a:xfrm>
-            <a:off x="5303520" y="5120640"/>
-            <a:ext cx="6473952" cy="1170432"/>
+            <a:off x="6355080" y="4096512"/>
+            <a:ext cx="5422392" cy="1143000"/>
           </a:xfrm>
           <a:prstGeom prst="rect">
             <a:avLst/>
@@ -14816,14 +14937,14 @@
       </p:sp>
       <p:sp>
         <p:nvSpPr>
-          <p:cNvPr id="12" name="text-150"/>
+          <p:cNvPr id="9" name="text-147"/>
           <p:cNvSpPr txBox="1"/>
           <p:nvPr/>
         </p:nvSpPr>
         <p:spPr>
           <a:xfrm>
-            <a:off x="5468112" y="5175504"/>
-            <a:ext cx="6172200" cy="1060704"/>
+            <a:off x="6519672" y="4133088"/>
+            <a:ext cx="5093208" cy="1069848"/>
           </a:xfrm>
           <a:prstGeom prst="rect">
             <a:avLst/>
@@ -14839,7 +14960,7 @@
               <a:buNone/>
             </a:pPr>
             <a:r>
-              <a:rPr lang="en-US" sz="1250" dirty="0">
+              <a:rPr lang="en-US" sz="1350" dirty="0">
                 <a:solidFill>
                   <a:schemeClr val="tx1"/>
                 </a:solidFill>
@@ -14847,13 +14968,38 @@
                 <a:ea typeface="Arial" pitchFamily="34" charset="-122"/>
                 <a:cs typeface="Arial" pitchFamily="34" charset="-120"/>
               </a:rPr>
-              <a:t>Every grounded aircraft-day is counted once, under its highest-priority reason, so the causes add up to the gap exactly — a unit-tested invariant, not a chart. </a:t>
-            </a:r>
+              <a:t>Every grounded aircraft-day is counted once, under its highest-priority reason, so the causes add up to the gap exactly. It is a unit-tested invariant, not a chart.</a:t>
+            </a:r>
+            <a:endParaRPr lang="en-US" sz="1350" dirty="0"/>
+          </a:p>
+        </p:txBody>
+      </p:sp>
+      <p:sp>
+        <p:nvSpPr>
+          <p:cNvPr id="10" name="text-148"/>
+          <p:cNvSpPr txBox="1"/>
+          <p:nvPr/>
+        </p:nvSpPr>
+        <p:spPr>
+          <a:xfrm>
+            <a:off x="6355080" y="5440680"/>
+            <a:ext cx="5422392" cy="548640"/>
+          </a:xfrm>
+          <a:prstGeom prst="rect">
+            <a:avLst/>
+          </a:prstGeom>
+          <a:noFill/>
+          <a:ln/>
+        </p:spPr>
+        <p:txBody>
+          <a:bodyPr wrap="square" lIns="0" tIns="0" rIns="0" bIns="0" rtlCol="0" anchor="ctr"/>
+          <a:lstStyle/>
+          <a:p>
             <a:pPr indent="0" marL="0">
               <a:buNone/>
             </a:pPr>
             <a:r>
-              <a:rPr lang="en-US" sz="1250" b="1" dirty="0">
+              <a:rPr lang="en-US" sz="1700" b="1" dirty="0">
                 <a:solidFill>
                   <a:schemeClr val="tx2"/>
                 </a:solidFill>
@@ -14863,7 +15009,7 @@
               </a:rPr>
               <a:t>This is the screen a Base Maintenance Officer opens at 0700.</a:t>
             </a:r>
-            <a:endParaRPr lang="en-US" sz="1250" dirty="0"/>
+            <a:endParaRPr lang="en-US" sz="1700" dirty="0"/>
           </a:p>
         </p:txBody>
       </p:sp>

</xml_diff>

<commit_message>
Deck: screenshots of the new app shell, two-tone wordmark, height-fitted images
Co-Authored-By: Claude Opus 5.5 <noreply@anthropic.com>
</commit_message>
<xml_diff>
--- a/deck/FLIGHTLINE_SIH26249.pptx
+++ b/deck/FLIGHTLINE_SIH26249.pptx
@@ -116,30 +116,30 @@
   <p:extLst>
     <p:ext uri="{521415D9-36F7-43E2-AB2F-B90AF26B5E84}">
       <p14:sectionLst xmlns:p14="http://schemas.microsoft.com/office/powerpoint/2010/main">
-        <p14:section name="Title" id="{a249e415-afad-a803-38c8-89ddc65ddc68}">
+        <p14:section name="Title" id="{280338a0-614d-2ed4-eb20-46a525a6feb4}">
           <p14:sldIdLst>
             <p14:sldId id="256"/>
           </p14:sldIdLst>
         </p14:section>
-        <p14:section name="Problem and idea" id="{b0bdbec6-43d5-d0e7-3a24-989a1805be96}">
+        <p14:section name="Problem and idea" id="{5bee7de6-3daa-7213-ca8a-67ec6adcf0f0}">
           <p14:sldIdLst>
             <p14:sldId id="257"/>
             <p14:sldId id="258"/>
           </p14:sldIdLst>
         </p14:section>
-        <p14:section name="How it works" id="{182d69d5-71e1-7184-0f0d-2daa37d6a7b8}">
+        <p14:section name="How it works" id="{2d337a84-31ec-6d61-f734-3d1839212ecd}">
           <p14:sldIdLst>
             <p14:sldId id="259"/>
             <p14:sldId id="260"/>
             <p14:sldId id="261"/>
           </p14:sldIdLst>
         </p14:section>
-        <p14:section name="Demo" id="{69e4deac-7ff5-f330-8f66-c46086321345}">
+        <p14:section name="Demo" id="{8a624a27-0f29-2fec-0947-2ad6fcc84a7c}">
           <p14:sldIdLst>
             <p14:sldId id="262"/>
           </p14:sldIdLst>
         </p14:section>
-        <p14:section name="Feasibility and impact" id="{0e3e05eb-9742-5c36-e04a-c0eeb1249455}">
+        <p14:section name="Feasibility and impact" id="{552e080b-0664-7e76-0ae4-9933ed5f7c8a}">
           <p14:sldIdLst>
             <p14:sldId id="263"/>
             <p14:sldId id="264"/>
@@ -3215,6 +3215,40 @@
               <a:buNone/>
             </a:pPr>
             <a:r>
+              <a:rPr lang="en-US" sz="2000" b="1" spc="200" kern="0" dirty="0">
+                <a:solidFill>
+                  <a:srgbClr val="000000"/>
+                </a:solidFill>
+                <a:latin typeface="Arial" pitchFamily="34" charset="0"/>
+                <a:ea typeface="Arial" pitchFamily="34" charset="-122"/>
+                <a:cs typeface="Arial" pitchFamily="34" charset="-120"/>
+              </a:rPr>
+              <a:t>FLIGHT</a:t>
+            </a:r>
+            <a:pPr indent="0" marL="0">
+              <a:spcAft>
+                <a:spcPts val="1400"/>
+              </a:spcAft>
+              <a:buNone/>
+            </a:pPr>
+            <a:r>
+              <a:rPr lang="en-US" sz="2000" b="1" spc="200" kern="0" dirty="0">
+                <a:solidFill>
+                  <a:srgbClr val="A3196F"/>
+                </a:solidFill>
+                <a:latin typeface="Arial" pitchFamily="34" charset="0"/>
+                <a:ea typeface="Arial" pitchFamily="34" charset="-122"/>
+                <a:cs typeface="Arial" pitchFamily="34" charset="-120"/>
+              </a:rPr>
+              <a:t>LINE</a:t>
+            </a:r>
+            <a:pPr indent="0" marL="0">
+              <a:spcAft>
+                <a:spcPts val="1400"/>
+              </a:spcAft>
+              <a:buNone/>
+            </a:pPr>
+            <a:r>
               <a:rPr lang="en-US" sz="2000" dirty="0">
                 <a:solidFill>
                   <a:srgbClr val="000000"/>
@@ -3223,7 +3257,7 @@
                 <a:ea typeface="Arial" pitchFamily="34" charset="-122"/>
                 <a:cs typeface="Arial" pitchFamily="34" charset="-120"/>
               </a:rPr>
-              <a:t>FLIGHTLINE — Fleet Availability Twin</a:t>
+              <a:t> — Fleet Availability Twin</a:t>
             </a:r>
             <a:endParaRPr lang="en-US" sz="2000" dirty="0"/>
           </a:p>
@@ -4566,6 +4600,34 @@
               <a:buNone/>
             </a:pPr>
             <a:r>
+              <a:rPr lang="en-US" sz="2000" b="1" spc="200" kern="0" dirty="0">
+                <a:solidFill>
+                  <a:schemeClr val="tx1"/>
+                </a:solidFill>
+                <a:latin typeface="Arial" pitchFamily="34" charset="0"/>
+                <a:ea typeface="Arial" pitchFamily="34" charset="-122"/>
+                <a:cs typeface="Arial" pitchFamily="34" charset="-120"/>
+              </a:rPr>
+              <a:t>FLIGHT</a:t>
+            </a:r>
+            <a:pPr indent="0" marL="0">
+              <a:buNone/>
+            </a:pPr>
+            <a:r>
+              <a:rPr lang="en-US" sz="2000" b="1" spc="200" kern="0" dirty="0">
+                <a:solidFill>
+                  <a:srgbClr val="A3196F"/>
+                </a:solidFill>
+                <a:latin typeface="Arial" pitchFamily="34" charset="0"/>
+                <a:ea typeface="Arial" pitchFamily="34" charset="-122"/>
+                <a:cs typeface="Arial" pitchFamily="34" charset="-120"/>
+              </a:rPr>
+              <a:t>LINE</a:t>
+            </a:r>
+            <a:pPr indent="0" marL="0">
+              <a:buNone/>
+            </a:pPr>
+            <a:r>
               <a:rPr lang="en-US" sz="2000" b="1" dirty="0">
                 <a:solidFill>
                   <a:schemeClr val="tx1"/>
@@ -4574,7 +4636,7 @@
                 <a:ea typeface="Arial" pitchFamily="34" charset="-122"/>
                 <a:cs typeface="Arial" pitchFamily="34" charset="-120"/>
               </a:rPr>
-              <a:t>FLIGHTLINE — Fleet Availability Twin</a:t>
+              <a:t> — Fleet Availability Twin</a:t>
             </a:r>
             <a:endParaRPr lang="en-US" sz="2000" dirty="0"/>
           </a:p>
@@ -10662,8 +10724,8 @@
         </p:blipFill>
         <p:spPr>
           <a:xfrm>
-            <a:off x="8229600" y="1115568"/>
-            <a:ext cx="3547872" cy="4431771"/>
+            <a:off x="8819823" y="1115568"/>
+            <a:ext cx="2957649" cy="4754880"/>
           </a:xfrm>
           <a:prstGeom prst="rect">
             <a:avLst/>
@@ -10678,8 +10740,8 @@
         </p:nvSpPr>
         <p:spPr>
           <a:xfrm>
-            <a:off x="8229600" y="1115568"/>
-            <a:ext cx="3547872" cy="4431771"/>
+            <a:off x="8819823" y="1115568"/>
+            <a:ext cx="2957649" cy="4754880"/>
           </a:xfrm>
           <a:prstGeom prst="rect">
             <a:avLst/>
@@ -10700,7 +10762,7 @@
         </p:nvSpPr>
         <p:spPr>
           <a:xfrm>
-            <a:off x="8229600" y="5602203"/>
+            <a:off x="8229600" y="5925312"/>
             <a:ext cx="3547872" cy="274320"/>
           </a:xfrm>
           <a:prstGeom prst="rect">
@@ -10713,7 +10775,7 @@
           <a:bodyPr wrap="square" lIns="0" tIns="0" rIns="0" bIns="0" rtlCol="0" anchor="t"/>
           <a:lstStyle/>
           <a:p>
-            <a:pPr indent="0" marL="0">
+            <a:pPr algn="r" indent="0" marL="0">
               <a:buNone/>
             </a:pPr>
             <a:r>
@@ -11345,7 +11407,7 @@
         <p:spPr>
           <a:xfrm>
             <a:off x="4114800" y="1115568"/>
-            <a:ext cx="7662672" cy="3317244"/>
+            <a:ext cx="7662672" cy="3132539"/>
           </a:xfrm>
           <a:prstGeom prst="rect">
             <a:avLst/>
@@ -11361,7 +11423,7 @@
         <p:spPr>
           <a:xfrm>
             <a:off x="4114800" y="1115568"/>
-            <a:ext cx="7662672" cy="3317244"/>
+            <a:ext cx="7662672" cy="3132539"/>
           </a:xfrm>
           <a:prstGeom prst="rect">
             <a:avLst/>
@@ -11382,7 +11444,7 @@
         </p:nvSpPr>
         <p:spPr>
           <a:xfrm>
-            <a:off x="4114800" y="4524252"/>
+            <a:off x="4114800" y="4339547"/>
             <a:ext cx="7662672" cy="457200"/>
           </a:xfrm>
           <a:prstGeom prst="rect">
@@ -11463,8 +11525,8 @@
         </p:nvSpPr>
         <p:spPr>
           <a:xfrm>
-            <a:off x="4114800" y="5091180"/>
-            <a:ext cx="7662672" cy="1172460"/>
+            <a:off x="4114800" y="4906475"/>
+            <a:ext cx="7662672" cy="1357165"/>
           </a:xfrm>
           <a:prstGeom prst="rect">
             <a:avLst/>
@@ -11488,8 +11550,8 @@
         </p:nvSpPr>
         <p:spPr>
           <a:xfrm>
-            <a:off x="4279392" y="5136900"/>
-            <a:ext cx="7315200" cy="1081020"/>
+            <a:off x="4279392" y="4952195"/>
+            <a:ext cx="7315200" cy="1265725"/>
           </a:xfrm>
           <a:prstGeom prst="rect">
             <a:avLst/>
@@ -13659,7 +13721,7 @@
         <p:spPr>
           <a:xfrm>
             <a:off x="411480" y="1600200"/>
-            <a:ext cx="5669280" cy="4491248"/>
+            <a:ext cx="5669280" cy="4383277"/>
           </a:xfrm>
           <a:prstGeom prst="rect">
             <a:avLst/>
@@ -13675,7 +13737,7 @@
         <p:spPr>
           <a:xfrm>
             <a:off x="411480" y="1600200"/>
-            <a:ext cx="5669280" cy="4491248"/>
+            <a:ext cx="5669280" cy="4383277"/>
           </a:xfrm>
           <a:prstGeom prst="rect">
             <a:avLst/>

</xml_diff>